<commit_message>
Agrega diapositivas de Sesión 1, 2 y 3 (v2)
</commit_message>
<xml_diff>
--- a/Diapositivas/Sesion1_Fundamentos_etica_alcance_v2.pptx
+++ b/Diapositivas/Sesion1_Fundamentos_etica_alcance_v2.pptx
@@ -1917,6 +1917,7 @@
               <a:t>OBJETIVO DE LA DIAPOSITIVA:
 Que cada participante configure, en su propia VM, BIND como servidor DNS local autoritativo para laboratorio-bacci.test, incluyendo el registro comodín (wildcard) que usa el Laboratorio 3 (Sesión 4).
 NOTAS DETALLADAS DEL EXPOSITOR:
+Nota importante sobre el nombre del servicio: el paquete se llama bind9, pero desde Debian 11 (y por lo tanto en Kali, que se basa en Debian) el servicio systemd se llama named — sudo systemctl restart bind9 falla con "Unit bind9.service not found". Usa siempre sudo systemctl restart named / sudo systemctl enable named. Si tu instalación sí trae el alias bind9.service, ambos comandos funcionan igual, pero named es el nombre que funciona en cualquier versión.
 Contenido de /etc/bind/db.laboratorio-bacci.test:
 $TTL 300
 @ IN SOA ns.laboratorio-bacci.test. admin.laboratorio-bacci.test. ( 2026081601 3600 900 604800 300 )
@@ -1939,7 +1940,7 @@
 EJEMPLO O ANALOGÍA:
 Una zona BIND es como un directorio telefónico que tú mismo administras para el dominio de laboratorio: cada registro (A, CNAME, MX, TXT) es una entrada de ese directorio, y el comodín (*) es la entrada "si no está en la lista, igual contesta este número".
 COMANDO / DEMOSTRACIÓN:
-sudo apt install -y bind9 &amp;&amp; sudo systemctl restart bind9 &amp;&amp; sudo systemctl enable bind9
+sudo apt install -y bind9 &amp;&amp; sudo systemctl restart named &amp;&amp; sudo systemctl enable named
 PREGUNTA DE PARTICIPACIÓN:
 ¿Por qué dev y old-portal usan un registro TXT en vez de simplemente no aparecer en la zona?
 TRANSICIÓN A LA SIGUIENTE DIAPOSITIVA:
@@ -2232,11 +2233,11 @@
               <a:t>OBJETIVO DE LA DIAPOSITIVA:
 Completar la preparación del sitio HTTPS de práctica: firmar el certificado del servidor y dejar el sitio corriendo y verificado en el puerto 8443, antes de que el checklist LAB-READY lo dé por hecho.
 NOTAS DETALLADAS DEL EXPOSITOR:
-openssl s_server queda ocupando la terminal mientras el sitio está arriba; para dejarlo corriendo en segundo plano se puede lanzar con &amp; al final del comando, o en una terminal/pestaña dedicada. Para ver el sitio en Firefox sin advertencia de certificado, hay que importar únicamente lab-ca.crt (nunca lab-ca.key) en Configuración → Privacidad y seguridad → Certificados → Ver certificados → Autoridades → Importar, marcando "confiar para identificar sitios web" — el mismo mecanismo que se usará después con la CA de Burp (Sesión 6) y de ZAP (Sesión 7). Si curl devuelve error de conexión, lo primero es confirmar que openssl s_server sigue corriendo en su terminal.
+Usar -www (minúscula), no -WWW (mayúscula): -WWW hace que openssl interprete la ruta pedida por el cliente como un archivo a servir desde el directorio actual — al pedir la URL sin ninguna ruta (solo el dominio), el navegador solicita "/", openssl le quita la barra inicial y trata de abrir un archivo llamado "" (vacío), lo que produce el error real "Error opening '' ... BIO_new_file" reportado por un participante. -www (minúscula) no abre ningún archivo: devuelve una página de estado con los datos de la sesión TLS negociada (cifrado, protocolo, certificado) — más simple y, para este laboratorio, más útil que servir un archivo real. openssl s_server queda ocupando la terminal mientras el sitio está arriba; para dejarlo corriendo en segundo plano se puede lanzar con &amp; al final del comando, o en una terminal/pestaña dedicada. Para ver el sitio en Firefox sin advertencia de certificado, hay que importar únicamente lab-ca.crt (nunca lab-ca.key) en Configuración → Privacidad y seguridad → Certificados → Ver certificados → Autoridades → Importar, marcando "confiar para identificar sitios web" — el mismo mecanismo que se usará después con la CA de Burp (Sesión 6) y de ZAP (Sesión 7). Si curl devuelve error de conexión, lo primero es confirmar que openssl s_server sigue corriendo en su terminal.
 EJEMPLO O ANALOGÍA:
-openssl s_server -WWW es un servidor HTTPS mínimo, suficiente para generar tráfico real de práctica sin instalar un servidor web completo.
+openssl s_server -www es un servidor HTTPS mínimo que responde con los datos de la sesión TLS (cifrado, protocolo, certificado) en vez de una página real — suficiente para generar tráfico HTTPS real de práctica sin instalar un servidor web completo ni depender de un archivo índice.
 COMANDO / DEMOSTRACIÓN:
-openssl x509 -req -in server.csr -CA lab-ca.crt -CAkey lab-ca.key -CAcreateserial -out server.crt -days 365 -sha256 &amp;&amp; openssl s_server -accept 8443 -cert server.crt -key server.key -WWW
+openssl x509 -req -in server.csr -CA lab-ca.crt -CAkey lab-ca.key -CAcreateserial -out server.crt -days 365 -sha256 &amp;&amp; openssl s_server -accept 8443 -cert server.crt -key server.key -www
 PREGUNTA DE PARTICIPACIÓN:
 ¿Qué verían en Firefox si intentan abrir el sitio antes de importar lab-ca.crt como CA confiable?
 TRANSICIÓN A LA SIGUIENTE DIAPOSITIVA:
@@ -15736,7 +15737,7 @@
                 <a:ea typeface="Courier New" pitchFamily="34" charset="-122"/>
                 <a:cs typeface="Courier New" pitchFamily="34" charset="-120"/>
               </a:rPr>
-              <a:t>sudo systemctl restart bind9 &amp;&amp; sudo systemctl enable bind9</a:t>
+              <a:t>sudo systemctl restart named &amp;&amp; sudo systemctl enable named</a:t>
             </a:r>
             <a:endParaRPr lang="en-US" sz="1300" dirty="0"/>
           </a:p>
@@ -15775,7 +15776,7 @@
                 <a:ea typeface="Roboto" pitchFamily="34" charset="-122"/>
                 <a:cs typeface="Roboto" pitchFamily="34" charset="-120"/>
               </a:rPr>
-              <a:t>Aplica los cambios y deja BIND activo tras reiniciar la VM</a:t>
+              <a:t>Aplica los cambios y deja BIND activo tras reiniciar la VM (el servicio systemd se llama named, no bind9 — ver nota)</a:t>
             </a:r>
             <a:endParaRPr lang="en-US" sz="1100" dirty="0"/>
           </a:p>
@@ -17917,7 +17918,7 @@
                 <a:ea typeface="Courier New" pitchFamily="34" charset="-122"/>
                 <a:cs typeface="Courier New" pitchFamily="34" charset="-120"/>
               </a:rPr>
-              <a:t>openssl s_server -accept 8443 -cert server.crt -key server.key -WWW</a:t>
+              <a:t>openssl s_server -accept 8443 -cert server.crt -key server.key -www</a:t>
             </a:r>
             <a:endParaRPr lang="en-US" sz="1300" dirty="0"/>
           </a:p>
@@ -17956,7 +17957,7 @@
                 <a:ea typeface="Roboto" pitchFamily="34" charset="-122"/>
                 <a:cs typeface="Roboto" pitchFamily="34" charset="-120"/>
               </a:rPr>
-              <a:t>Levanta el sitio HTTPS de práctica en el puerto 8443 (deja la terminal ocupada; Ctrl+C para detener)</a:t>
+              <a:t>Levanta el sitio HTTPS de práctica en el puerto 8443 (deja la terminal ocupada; Ctrl+C para detener) — usa -www minúscula, no -WWW</a:t>
             </a:r>
             <a:endParaRPr lang="en-US" sz="1100" dirty="0"/>
           </a:p>

</xml_diff>